<commit_message>
docs: grant deck V6 edits — email info@kuja.org, localization as core advantage, two-sided reporting/compliance, in-context AI per persona
- Email corrected to info@kuja.org (title + ask slides)
- Somali/Swahili/Arabic/French named prominently (title, accessibility hero card, why-we-win)
- Reporting slide now two-sided: NGO produces quality reports (real-time in-context help + reminders + coach + pre-check); donor receives pre-scored deliverables per requirement
- AI slide reframed around in-context guidance for every persona (apply, Trust forms, donor design/review, reviewer score)

Co-Authored-By: Claude Opus 4.8 <noreply@anthropic.com>
</commit_message>
<xml_diff>
--- a/docs/Kuja_Grant_Pitch_Deck_V6_Aug2026.pptx
+++ b/docs/Kuja_Grant_Pitch_Deck_V6_Aug2026.pptx
@@ -2540,7 +2540,7 @@
               <a:buNone/>
             </a:pPr>
             <a:r>
-              <a:rPr lang="en-US" sz="1250" dirty="0">
+              <a:rPr lang="en-US" sz="1200" dirty="0">
                 <a:solidFill>
                   <a:srgbClr val="C9B6A6"/>
                 </a:solidFill>
@@ -2548,9 +2548,37 @@
                 <a:ea typeface="Calibri" pitchFamily="34" charset="-122"/>
                 <a:cs typeface="Calibri" pitchFamily="34" charset="-120"/>
               </a:rPr>
-              <a:t>AI-native  ·  Six languages  ·  Built BY and FOR the Global South  ·  Production-deployed today</a:t>
-            </a:r>
-            <a:endParaRPr lang="en-US" sz="1250" dirty="0"/>
+              <a:t>AI-native  ·  Six languages at parity: </a:t>
+            </a:r>
+            <a:pPr indent="0" marL="0">
+              <a:buNone/>
+            </a:pPr>
+            <a:r>
+              <a:rPr lang="en-US" sz="1200" b="1" dirty="0">
+                <a:solidFill>
+                  <a:srgbClr val="F0A44A"/>
+                </a:solidFill>
+                <a:latin typeface="Calibri" pitchFamily="34" charset="0"/>
+                <a:ea typeface="Calibri" pitchFamily="34" charset="-122"/>
+                <a:cs typeface="Calibri" pitchFamily="34" charset="-120"/>
+              </a:rPr>
+              <a:t>Somali · Swahili · Arabic · French</a:t>
+            </a:r>
+            <a:pPr indent="0" marL="0">
+              <a:buNone/>
+            </a:pPr>
+            <a:r>
+              <a:rPr lang="en-US" sz="1200" dirty="0">
+                <a:solidFill>
+                  <a:srgbClr val="C9B6A6"/>
+                </a:solidFill>
+                <a:latin typeface="Calibri" pitchFamily="34" charset="0"/>
+                <a:ea typeface="Calibri" pitchFamily="34" charset="-122"/>
+                <a:cs typeface="Calibri" pitchFamily="34" charset="-120"/>
+              </a:rPr>
+              <a:t> · English · Spanish  ·  Production-deployed today</a:t>
+            </a:r>
+            <a:endParaRPr lang="en-US" sz="1200" dirty="0"/>
           </a:p>
         </p:txBody>
       </p:sp>
@@ -2649,7 +2677,7 @@
                 <a:ea typeface="Calibri" pitchFamily="34" charset="-122"/>
                 <a:cs typeface="Calibri" pitchFamily="34" charset="-120"/>
               </a:rPr>
-              <a:t>kuja@adeso.org</a:t>
+              <a:t>info@kuja.org</a:t>
             </a:r>
             <a:endParaRPr lang="en-US" sz="1150" dirty="0"/>
           </a:p>
@@ -2839,7 +2867,7 @@
                 <a:ea typeface="Calibri" pitchFamily="34" charset="-122"/>
                 <a:cs typeface="Calibri" pitchFamily="34" charset="-120"/>
               </a:rPr>
-              <a:t>WhatsApp, voice notes, photos, mobile-first, six languages — the way Global South work actually happens, not a desktop form in English.</a:t>
+              <a:t>Full parity in Somali, Swahili, Arabic and French — plus WhatsApp, voice, photos and mobile-first. The way Global South work actually happens, not a desktop form in English.</a:t>
             </a:r>
             <a:endParaRPr lang="en-US" sz="1450" dirty="0"/>
           </a:p>
@@ -2889,7 +2917,7 @@
             </a:avLst>
           </a:prstGeom>
           <a:solidFill>
-            <a:srgbClr val="F0A44A"/>
+            <a:srgbClr val="C2410C"/>
           </a:solidFill>
           <a:ln/>
         </p:spPr>
@@ -2902,8 +2930,8 @@
         </p:nvSpPr>
         <p:spPr>
           <a:xfrm>
-            <a:off x="777240" y="2532888"/>
-            <a:ext cx="3055010" cy="365760"/>
+            <a:off x="777240" y="2514600"/>
+            <a:ext cx="3055010" cy="384048"/>
           </a:xfrm>
           <a:prstGeom prst="rect">
             <a:avLst/>
@@ -2921,17 +2949,17 @@
               <a:buNone/>
             </a:pPr>
             <a:r>
-              <a:rPr lang="en-US" sz="1300" b="1" dirty="0">
-                <a:solidFill>
-                  <a:srgbClr val="FAF4EE"/>
-                </a:solidFill>
-                <a:latin typeface="Calibri" pitchFamily="34" charset="0"/>
-                <a:ea typeface="Calibri" pitchFamily="34" charset="-122"/>
-                <a:cs typeface="Calibri" pitchFamily="34" charset="-120"/>
-              </a:rPr>
-              <a:t>WhatsApp</a:t>
-            </a:r>
-            <a:endParaRPr lang="en-US" sz="1300" dirty="0"/>
+              <a:rPr lang="en-US" sz="1250" b="1" dirty="0">
+                <a:solidFill>
+                  <a:srgbClr val="C2410C"/>
+                </a:solidFill>
+                <a:latin typeface="Calibri" pitchFamily="34" charset="0"/>
+                <a:ea typeface="Calibri" pitchFamily="34" charset="-122"/>
+                <a:cs typeface="Calibri" pitchFamily="34" charset="-120"/>
+              </a:rPr>
+              <a:t>Somali · Swahili · Arabic · French</a:t>
+            </a:r>
+            <a:endParaRPr lang="en-US" sz="1250" dirty="0"/>
           </a:p>
         </p:txBody>
       </p:sp>
@@ -2943,7 +2971,7 @@
         </p:nvSpPr>
         <p:spPr>
           <a:xfrm>
-            <a:off x="777240" y="2898648"/>
+            <a:off x="777240" y="2916936"/>
             <a:ext cx="3055010" cy="731520"/>
           </a:xfrm>
           <a:prstGeom prst="rect">
@@ -2973,7 +3001,7 @@
                 <a:ea typeface="Calibri" pitchFamily="34" charset="-122"/>
                 <a:cs typeface="Calibri" pitchFamily="34" charset="-120"/>
               </a:rPr>
-              <a:t>Submit a status, get a deadline nudge, answer a clarification — all from WhatsApp, the channel CSOs already use.</a:t>
+              <a:t>Six-language parity at the WORKFLOW level (with English &amp; Spanish) — not translated strings, but translated AI behaviour. Our core advantage in markets mainstream tools ignore.</a:t>
             </a:r>
             <a:endParaRPr lang="en-US" sz="1050" dirty="0"/>
           </a:p>
@@ -3036,8 +3064,8 @@
         </p:nvSpPr>
         <p:spPr>
           <a:xfrm>
-            <a:off x="4591202" y="2532888"/>
-            <a:ext cx="3055010" cy="365760"/>
+            <a:off x="4591202" y="2514600"/>
+            <a:ext cx="3055010" cy="384048"/>
           </a:xfrm>
           <a:prstGeom prst="rect">
             <a:avLst/>
@@ -3063,7 +3091,7 @@
                 <a:ea typeface="Calibri" pitchFamily="34" charset="-122"/>
                 <a:cs typeface="Calibri" pitchFamily="34" charset="-120"/>
               </a:rPr>
-              <a:t>Voice-to-report</a:t>
+              <a:t>WhatsApp</a:t>
             </a:r>
             <a:endParaRPr lang="en-US" sz="1300" dirty="0"/>
           </a:p>
@@ -3077,7 +3105,7 @@
         </p:nvSpPr>
         <p:spPr>
           <a:xfrm>
-            <a:off x="4591202" y="2898648"/>
+            <a:off x="4591202" y="2916936"/>
             <a:ext cx="3055010" cy="731520"/>
           </a:xfrm>
           <a:prstGeom prst="rect">
@@ -3107,7 +3135,7 @@
                 <a:ea typeface="Calibri" pitchFamily="34" charset="-122"/>
                 <a:cs typeface="Calibri" pitchFamily="34" charset="-120"/>
               </a:rPr>
-              <a:t>A field officer speaks in Swahili; AI transcribes, structures and translates. Five minutes vs an hour of typing.</a:t>
+              <a:t>Submit a status, get a deadline nudge, answer a clarification — all from WhatsApp, the channel CSOs already use.</a:t>
             </a:r>
             <a:endParaRPr lang="en-US" sz="1050" dirty="0"/>
           </a:p>
@@ -3170,8 +3198,8 @@
         </p:nvSpPr>
         <p:spPr>
           <a:xfrm>
-            <a:off x="8405165" y="2532888"/>
-            <a:ext cx="3055010" cy="365760"/>
+            <a:off x="8405165" y="2514600"/>
+            <a:ext cx="3055010" cy="384048"/>
           </a:xfrm>
           <a:prstGeom prst="rect">
             <a:avLst/>
@@ -3197,7 +3225,7 @@
                 <a:ea typeface="Calibri" pitchFamily="34" charset="-122"/>
                 <a:cs typeface="Calibri" pitchFamily="34" charset="-120"/>
               </a:rPr>
-              <a:t>Photo-as-evidence</a:t>
+              <a:t>Voice-to-report</a:t>
             </a:r>
             <a:endParaRPr lang="en-US" sz="1300" dirty="0"/>
           </a:p>
@@ -3211,7 +3239,7 @@
         </p:nvSpPr>
         <p:spPr>
           <a:xfrm>
-            <a:off x="8405165" y="2898648"/>
+            <a:off x="8405165" y="2916936"/>
             <a:ext cx="3055010" cy="731520"/>
           </a:xfrm>
           <a:prstGeom prst="rect">
@@ -3241,7 +3269,7 @@
                 <a:ea typeface="Calibri" pitchFamily="34" charset="-122"/>
                 <a:cs typeface="Calibri" pitchFamily="34" charset="-120"/>
               </a:rPr>
-              <a:t>Snap the receipt, the borehole, the training. AI labels, geo-tags and attaches to the right report line.</a:t>
+              <a:t>A field officer speaks in Swahili; AI transcribes, structures and translates. Five minutes vs an hour of typing.</a:t>
             </a:r>
             <a:endParaRPr lang="en-US" sz="1050" dirty="0"/>
           </a:p>
@@ -3304,8 +3332,8 @@
         </p:nvSpPr>
         <p:spPr>
           <a:xfrm>
-            <a:off x="777240" y="4123944"/>
-            <a:ext cx="3055010" cy="365760"/>
+            <a:off x="777240" y="4105656"/>
+            <a:ext cx="3055010" cy="384048"/>
           </a:xfrm>
           <a:prstGeom prst="rect">
             <a:avLst/>
@@ -3331,7 +3359,7 @@
                 <a:ea typeface="Calibri" pitchFamily="34" charset="-122"/>
                 <a:cs typeface="Calibri" pitchFamily="34" charset="-120"/>
               </a:rPr>
-              <a:t>Six-language parity</a:t>
+              <a:t>Photo-as-evidence</a:t>
             </a:r>
             <a:endParaRPr lang="en-US" sz="1300" dirty="0"/>
           </a:p>
@@ -3345,7 +3373,7 @@
         </p:nvSpPr>
         <p:spPr>
           <a:xfrm>
-            <a:off x="777240" y="4489704"/>
+            <a:off x="777240" y="4507992"/>
             <a:ext cx="3055010" cy="731520"/>
           </a:xfrm>
           <a:prstGeom prst="rect">
@@ -3375,7 +3403,7 @@
                 <a:ea typeface="Calibri" pitchFamily="34" charset="-122"/>
                 <a:cs typeface="Calibri" pitchFamily="34" charset="-120"/>
               </a:rPr>
-              <a:t>EN · FR · AR · SW · SO · ES at the workflow level — not just strings, but translated AI behaviour.</a:t>
+              <a:t>Snap the receipt, the borehole, the training. AI labels, geo-tags and attaches to the right report line.</a:t>
             </a:r>
             <a:endParaRPr lang="en-US" sz="1050" dirty="0"/>
           </a:p>
@@ -3438,8 +3466,8 @@
         </p:nvSpPr>
         <p:spPr>
           <a:xfrm>
-            <a:off x="4591202" y="4123944"/>
-            <a:ext cx="3055010" cy="365760"/>
+            <a:off x="4591202" y="4105656"/>
+            <a:ext cx="3055010" cy="384048"/>
           </a:xfrm>
           <a:prstGeom prst="rect">
             <a:avLst/>
@@ -3479,7 +3507,7 @@
         </p:nvSpPr>
         <p:spPr>
           <a:xfrm>
-            <a:off x="4591202" y="4489704"/>
+            <a:off x="4591202" y="4507992"/>
             <a:ext cx="3055010" cy="731520"/>
           </a:xfrm>
           <a:prstGeom prst="rect">
@@ -3572,8 +3600,8 @@
         </p:nvSpPr>
         <p:spPr>
           <a:xfrm>
-            <a:off x="8405165" y="4123944"/>
-            <a:ext cx="3055010" cy="365760"/>
+            <a:off x="8405165" y="4105656"/>
+            <a:ext cx="3055010" cy="384048"/>
           </a:xfrm>
           <a:prstGeom prst="rect">
             <a:avLst/>
@@ -3613,7 +3641,7 @@
         </p:nvSpPr>
         <p:spPr>
           <a:xfrm>
-            <a:off x="8405165" y="4489704"/>
+            <a:off x="8405165" y="4507992"/>
             <a:ext cx="3055010" cy="731520"/>
           </a:xfrm>
           <a:prstGeom prst="rect">
@@ -11963,7 +11991,7 @@
                 <a:ea typeface="Calibri" pitchFamily="34" charset="-122"/>
                 <a:cs typeface="Calibri" pitchFamily="34" charset="-120"/>
               </a:rPr>
-              <a:t>Built BY and FOR the Global South</a:t>
+              <a:t>Global-South-built · six languages</a:t>
             </a:r>
             <a:endParaRPr lang="en-US" sz="1250" dirty="0"/>
           </a:p>
@@ -12007,7 +12035,7 @@
                 <a:ea typeface="Calibri" pitchFamily="34" charset="-122"/>
                 <a:cs typeface="Calibri" pitchFamily="34" charset="-120"/>
               </a:rPr>
-              <a:t>WhatsApp, voice, photo, six languages, mobile-first — designed for the Tecno phone on 3G from day one, not localized after the fact.</a:t>
+              <a:t>Full parity in Somali, Swahili, Arabic and French (plus English &amp; Spanish). WhatsApp, voice, photo, mobile-first — designed for the Tecno phone on 3G, not localized after the fact.</a:t>
             </a:r>
             <a:endParaRPr lang="en-US" sz="980" dirty="0"/>
           </a:p>
@@ -14264,7 +14292,7 @@
                 <a:ea typeface="Calibri" pitchFamily="34" charset="-122"/>
                 <a:cs typeface="Calibri" pitchFamily="34" charset="-120"/>
               </a:rPr>
-              <a:t>kuja@adeso.org</a:t>
+              <a:t>info@kuja.org</a:t>
             </a:r>
             <a:pPr algn="ctr" indent="0" marL="0">
               <a:buNone/>
@@ -18137,7 +18165,7 @@
                 <a:ea typeface="Calibri" pitchFamily="34" charset="-122"/>
                 <a:cs typeface="Calibri" pitchFamily="34" charset="-120"/>
               </a:rPr>
-              <a:t>AI is woven into every stage — not a chatbot bolted on the side. Every surface cites its source and is telemetered for cost, latency and fallback.</a:t>
+              <a:t>AI guides every persona in context — the NGO as it applies and completes its Trust forms, the donor as it designs and reviews grants, the reviewer as it scores. Every surface cites its source.</a:t>
             </a:r>
             <a:endParaRPr lang="en-US" sz="1450" dirty="0"/>
           </a:p>
@@ -20631,7 +20659,7 @@
                 <a:ea typeface="Georgia" pitchFamily="34" charset="-122"/>
                 <a:cs typeface="Georgia" pitchFamily="34" charset="-120"/>
               </a:rPr>
-              <a:t>AI grades every report against the agreement.</a:t>
+              <a:t>Quality reports in. Scored deliverables out.</a:t>
             </a:r>
             <a:endParaRPr lang="en-US" sz="3000" dirty="0"/>
           </a:p>
@@ -20672,7 +20700,7 @@
                 <a:ea typeface="Calibri" pitchFamily="34" charset="-122"/>
                 <a:cs typeface="Calibri" pitchFamily="34" charset="-120"/>
               </a:rPr>
-              <a:t>The donor uploads the signed agreement once. AI extracts every requirement. Every NGO report is graded against it, per requirement, with citations.</a:t>
+              <a:t>AI supports the NGO in real time and in context as it reports — then hands the donor a deliverable already graded, per requirement, against the signed agreement.</a:t>
             </a:r>
             <a:endParaRPr lang="en-US" sz="1450" dirty="0"/>
           </a:p>
@@ -20686,12 +20714,12 @@
         </p:nvSpPr>
         <p:spPr>
           <a:xfrm>
-            <a:off x="502920" y="2377440"/>
-            <a:ext cx="3557930" cy="2286000"/>
+            <a:off x="502920" y="2331720"/>
+            <a:ext cx="5455768" cy="2743200"/>
           </a:xfrm>
           <a:prstGeom prst="roundRect">
             <a:avLst>
-              <a:gd name="adj" fmla="val 3600"/>
+              <a:gd name="adj" fmla="val 3000"/>
             </a:avLst>
           </a:prstGeom>
           <a:solidFill>
@@ -20713,8 +20741,8 @@
         </p:nvSpPr>
         <p:spPr>
           <a:xfrm>
-            <a:off x="502920" y="2377440"/>
-            <a:ext cx="82296" cy="2286000"/>
+            <a:off x="502920" y="2331720"/>
+            <a:ext cx="82296" cy="2743200"/>
           </a:xfrm>
           <a:prstGeom prst="roundRect">
             <a:avLst>
@@ -20722,7 +20750,7 @@
             </a:avLst>
           </a:prstGeom>
           <a:solidFill>
-            <a:srgbClr val="C2410C"/>
+            <a:srgbClr val="2DD4BF"/>
           </a:solidFill>
           <a:ln/>
         </p:spPr>
@@ -20735,34 +20763,36 @@
         </p:nvSpPr>
         <p:spPr>
           <a:xfrm>
-            <a:off x="777240" y="2596896"/>
-            <a:ext cx="1097280" cy="457200"/>
-          </a:xfrm>
-          <a:prstGeom prst="rect">
-            <a:avLst/>
-          </a:prstGeom>
-          <a:noFill/>
-          <a:ln/>
-        </p:spPr>
-        <p:txBody>
-          <a:bodyPr wrap="square" rtlCol="0" anchor="ctr"/>
+            <a:off x="795528" y="2569464"/>
+            <a:ext cx="4907128" cy="292608"/>
+          </a:xfrm>
+          <a:prstGeom prst="rect">
+            <a:avLst/>
+          </a:prstGeom>
+          <a:noFill/>
+          <a:ln/>
+        </p:spPr>
+        <p:txBody>
+          <a:bodyPr wrap="square" rtlCol="0" anchor="ctr">
+            <a:normAutofit/>
+          </a:bodyPr>
           <a:lstStyle/>
           <a:p>
             <a:pPr indent="0" marL="0">
               <a:buNone/>
             </a:pPr>
             <a:r>
-              <a:rPr lang="en-US" sz="2200" b="1" dirty="0">
-                <a:solidFill>
-                  <a:srgbClr val="F97316"/>
-                </a:solidFill>
-                <a:latin typeface="Georgia" pitchFamily="34" charset="0"/>
-                <a:ea typeface="Georgia" pitchFamily="34" charset="-122"/>
-                <a:cs typeface="Georgia" pitchFamily="34" charset="-120"/>
-              </a:rPr>
-              <a:t>01</a:t>
-            </a:r>
-            <a:endParaRPr lang="en-US" sz="2200" dirty="0"/>
+              <a:rPr lang="en-US" sz="1150" b="1" spc="50" kern="0" dirty="0">
+                <a:solidFill>
+                  <a:srgbClr val="2DD4BF"/>
+                </a:solidFill>
+                <a:latin typeface="Calibri" pitchFamily="34" charset="0"/>
+                <a:ea typeface="Calibri" pitchFamily="34" charset="-122"/>
+                <a:cs typeface="Calibri" pitchFamily="34" charset="-120"/>
+              </a:rPr>
+              <a:t>FOR THE NGO · PRODUCE A QUALITY, ACCURATE REPORT</a:t>
+            </a:r>
+            <a:endParaRPr lang="en-US" sz="1150" dirty="0"/>
           </a:p>
         </p:txBody>
       </p:sp>
@@ -20774,8 +20804,8 @@
         </p:nvSpPr>
         <p:spPr>
           <a:xfrm>
-            <a:off x="777240" y="3127248"/>
-            <a:ext cx="3055010" cy="548640"/>
+            <a:off x="795528" y="2935224"/>
+            <a:ext cx="4888840" cy="1965960"/>
           </a:xfrm>
           <a:prstGeom prst="rect">
             <a:avLst/>
@@ -20789,55 +20819,18 @@
           </a:bodyPr>
           <a:lstStyle/>
           <a:p>
-            <a:pPr indent="0" marL="0">
-              <a:buNone/>
-            </a:pPr>
-            <a:r>
-              <a:rPr lang="en-US" sz="1300" b="1" dirty="0">
-                <a:solidFill>
-                  <a:srgbClr val="FAF4EE"/>
-                </a:solidFill>
-                <a:latin typeface="Calibri" pitchFamily="34" charset="0"/>
-                <a:ea typeface="Calibri" pitchFamily="34" charset="-122"/>
-                <a:cs typeface="Calibri" pitchFamily="34" charset="-120"/>
-              </a:rPr>
-              <a:t>Agreement → AI obligation extract</a:t>
-            </a:r>
-            <a:endParaRPr lang="en-US" sz="1300" dirty="0"/>
-          </a:p>
-        </p:txBody>
-      </p:sp>
-      <p:sp>
-        <p:nvSpPr>
-          <p:cNvPr id="10" name="Text 8"/>
-          <p:cNvSpPr/>
-          <p:nvPr/>
-        </p:nvSpPr>
-        <p:spPr>
-          <a:xfrm>
-            <a:off x="777240" y="3694176"/>
-            <a:ext cx="3055010" cy="868680"/>
-          </a:xfrm>
-          <a:prstGeom prst="rect">
-            <a:avLst/>
-          </a:prstGeom>
-          <a:noFill/>
-          <a:ln/>
-        </p:spPr>
-        <p:txBody>
-          <a:bodyPr wrap="square" rtlCol="0" anchor="t">
-            <a:normAutofit/>
-          </a:bodyPr>
-          <a:lstStyle/>
-          <a:p>
-            <a:pPr indent="0" marL="0">
+            <a:pPr marL="152400" indent="-152400">
               <a:lnSpc>
-                <a:spcPct val="103000"/>
+                <a:spcPct val="100000"/>
               </a:lnSpc>
-              <a:buNone/>
-            </a:pPr>
-            <a:r>
-              <a:rPr lang="en-US" sz="1050" dirty="0">
+              <a:spcAft>
+                <a:spcPts val="600"/>
+              </a:spcAft>
+              <a:buSzPct val="100000"/>
+              <a:buChar char="•"/>
+            </a:pPr>
+            <a:r>
+              <a:rPr lang="en-US" sz="1100" dirty="0">
                 <a:solidFill>
                   <a:srgbClr val="C9B6A6"/>
                 </a:solidFill>
@@ -20845,26 +20838,122 @@
                 <a:ea typeface="Calibri" pitchFamily="34" charset="-122"/>
                 <a:cs typeface="Calibri" pitchFamily="34" charset="-120"/>
               </a:rPr>
-              <a:t>On upload, AI parses the agreement and structures every reporting requirement, deadline, deliverable and indicator. No data entry.</a:t>
-            </a:r>
-            <a:endParaRPr lang="en-US" sz="1050" dirty="0"/>
-          </a:p>
-        </p:txBody>
-      </p:sp>
-      <p:sp>
-        <p:nvSpPr>
-          <p:cNvPr id="11" name="Shape 9"/>
-          <p:cNvSpPr/>
-          <p:nvPr/>
-        </p:nvSpPr>
-        <p:spPr>
-          <a:xfrm>
-            <a:off x="4316882" y="2377440"/>
-            <a:ext cx="3557930" cy="2286000"/>
+              <a:t>Real-time, in-context guidance while writing — the field it belongs to, in plain language</a:t>
+            </a:r>
+            <a:endParaRPr lang="en-US" sz="1100" dirty="0"/>
+          </a:p>
+          <a:p>
+            <a:pPr marL="152400" indent="-152400">
+              <a:lnSpc>
+                <a:spcPct val="100000"/>
+              </a:lnSpc>
+              <a:spcAft>
+                <a:spcPts val="600"/>
+              </a:spcAft>
+              <a:buSzPct val="100000"/>
+              <a:buChar char="•"/>
+            </a:pPr>
+            <a:r>
+              <a:rPr lang="en-US" sz="1100" dirty="0">
+                <a:solidFill>
+                  <a:srgbClr val="C9B6A6"/>
+                </a:solidFill>
+                <a:latin typeface="Calibri" pitchFamily="34" charset="0"/>
+                <a:ea typeface="Calibri" pitchFamily="34" charset="-122"/>
+                <a:cs typeface="Calibri" pitchFamily="34" charset="-120"/>
+              </a:rPr>
+              <a:t>Reminders as deadlines approach, over the app and WhatsApp — nothing slips</a:t>
+            </a:r>
+            <a:endParaRPr lang="en-US" sz="1100" dirty="0"/>
+          </a:p>
+          <a:p>
+            <a:pPr marL="152400" indent="-152400">
+              <a:lnSpc>
+                <a:spcPct val="100000"/>
+              </a:lnSpc>
+              <a:spcAft>
+                <a:spcPts val="600"/>
+              </a:spcAft>
+              <a:buSzPct val="100000"/>
+              <a:buChar char="•"/>
+            </a:pPr>
+            <a:r>
+              <a:rPr lang="en-US" sz="1100" dirty="0">
+                <a:solidFill>
+                  <a:srgbClr val="C9B6A6"/>
+                </a:solidFill>
+                <a:latin typeface="Calibri" pitchFamily="34" charset="0"/>
+                <a:ea typeface="Calibri" pitchFamily="34" charset="-122"/>
+                <a:cs typeface="Calibri" pitchFamily="34" charset="-120"/>
+              </a:rPr>
+              <a:t>AI compliance coach: what is missing, why it matters, and how to fix it — inline</a:t>
+            </a:r>
+            <a:endParaRPr lang="en-US" sz="1100" dirty="0"/>
+          </a:p>
+          <a:p>
+            <a:pPr marL="152400" indent="-152400">
+              <a:lnSpc>
+                <a:spcPct val="100000"/>
+              </a:lnSpc>
+              <a:spcAft>
+                <a:spcPts val="600"/>
+              </a:spcAft>
+              <a:buSzPct val="100000"/>
+              <a:buChar char="•"/>
+            </a:pPr>
+            <a:r>
+              <a:rPr lang="en-US" sz="1100" dirty="0">
+                <a:solidFill>
+                  <a:srgbClr val="C9B6A6"/>
+                </a:solidFill>
+                <a:latin typeface="Calibri" pitchFamily="34" charset="0"/>
+                <a:ea typeface="Calibri" pitchFamily="34" charset="-122"/>
+                <a:cs typeface="Calibri" pitchFamily="34" charset="-120"/>
+              </a:rPr>
+              <a:t>A per-requirement pre-check before submit, so the report is complete and accurate</a:t>
+            </a:r>
+            <a:endParaRPr lang="en-US" sz="1100" dirty="0"/>
+          </a:p>
+          <a:p>
+            <a:pPr marL="152400" indent="-152400">
+              <a:lnSpc>
+                <a:spcPct val="100000"/>
+              </a:lnSpc>
+              <a:spcAft>
+                <a:spcPts val="600"/>
+              </a:spcAft>
+              <a:buSzPct val="100000"/>
+              <a:buChar char="•"/>
+            </a:pPr>
+            <a:r>
+              <a:rPr lang="en-US" sz="1100" dirty="0">
+                <a:solidFill>
+                  <a:srgbClr val="C9B6A6"/>
+                </a:solidFill>
+                <a:latin typeface="Calibri" pitchFamily="34" charset="0"/>
+                <a:ea typeface="Calibri" pitchFamily="34" charset="-122"/>
+                <a:cs typeface="Calibri" pitchFamily="34" charset="-120"/>
+              </a:rPr>
+              <a:t>Voice-to-report and photo-as-evidence where typing is the barrier</a:t>
+            </a:r>
+            <a:endParaRPr lang="en-US" sz="1100" dirty="0"/>
+          </a:p>
+        </p:txBody>
+      </p:sp>
+      <p:sp>
+        <p:nvSpPr>
+          <p:cNvPr id="10" name="Shape 8"/>
+          <p:cNvSpPr/>
+          <p:nvPr/>
+        </p:nvSpPr>
+        <p:spPr>
+          <a:xfrm>
+            <a:off x="6233008" y="2331720"/>
+            <a:ext cx="5455768" cy="2743200"/>
           </a:xfrm>
           <a:prstGeom prst="roundRect">
             <a:avLst>
-              <a:gd name="adj" fmla="val 3600"/>
+              <a:gd name="adj" fmla="val 3000"/>
             </a:avLst>
           </a:prstGeom>
           <a:solidFill>
@@ -20880,14 +20969,14 @@
       </p:sp>
       <p:sp>
         <p:nvSpPr>
-          <p:cNvPr id="12" name="Shape 10"/>
-          <p:cNvSpPr/>
-          <p:nvPr/>
-        </p:nvSpPr>
-        <p:spPr>
-          <a:xfrm>
-            <a:off x="4316882" y="2377440"/>
-            <a:ext cx="82296" cy="2286000"/>
+          <p:cNvPr id="11" name="Shape 9"/>
+          <p:cNvSpPr/>
+          <p:nvPr/>
+        </p:nvSpPr>
+        <p:spPr>
+          <a:xfrm>
+            <a:off x="6233008" y="2331720"/>
+            <a:ext cx="82296" cy="2743200"/>
           </a:xfrm>
           <a:prstGeom prst="roundRect">
             <a:avLst>
@@ -20902,53 +20991,55 @@
       </p:sp>
       <p:sp>
         <p:nvSpPr>
+          <p:cNvPr id="12" name="Text 10"/>
+          <p:cNvSpPr/>
+          <p:nvPr/>
+        </p:nvSpPr>
+        <p:spPr>
+          <a:xfrm>
+            <a:off x="6525616" y="2569464"/>
+            <a:ext cx="4907128" cy="292608"/>
+          </a:xfrm>
+          <a:prstGeom prst="rect">
+            <a:avLst/>
+          </a:prstGeom>
+          <a:noFill/>
+          <a:ln/>
+        </p:spPr>
+        <p:txBody>
+          <a:bodyPr wrap="square" rtlCol="0" anchor="ctr">
+            <a:normAutofit/>
+          </a:bodyPr>
+          <a:lstStyle/>
+          <a:p>
+            <a:pPr indent="0" marL="0">
+              <a:buNone/>
+            </a:pPr>
+            <a:r>
+              <a:rPr lang="en-US" sz="1150" b="1" spc="50" kern="0" dirty="0">
+                <a:solidFill>
+                  <a:srgbClr val="F0A44A"/>
+                </a:solidFill>
+                <a:latin typeface="Calibri" pitchFamily="34" charset="0"/>
+                <a:ea typeface="Calibri" pitchFamily="34" charset="-122"/>
+                <a:cs typeface="Calibri" pitchFamily="34" charset="-120"/>
+              </a:rPr>
+              <a:t>FOR THE DONOR · RECEIVE PRE-SCORED DELIVERABLES</a:t>
+            </a:r>
+            <a:endParaRPr lang="en-US" sz="1150" dirty="0"/>
+          </a:p>
+        </p:txBody>
+      </p:sp>
+      <p:sp>
+        <p:nvSpPr>
           <p:cNvPr id="13" name="Text 11"/>
           <p:cNvSpPr/>
           <p:nvPr/>
         </p:nvSpPr>
         <p:spPr>
           <a:xfrm>
-            <a:off x="4591202" y="2596896"/>
-            <a:ext cx="1097280" cy="457200"/>
-          </a:xfrm>
-          <a:prstGeom prst="rect">
-            <a:avLst/>
-          </a:prstGeom>
-          <a:noFill/>
-          <a:ln/>
-        </p:spPr>
-        <p:txBody>
-          <a:bodyPr wrap="square" rtlCol="0" anchor="ctr"/>
-          <a:lstStyle/>
-          <a:p>
-            <a:pPr indent="0" marL="0">
-              <a:buNone/>
-            </a:pPr>
-            <a:r>
-              <a:rPr lang="en-US" sz="2200" b="1" dirty="0">
-                <a:solidFill>
-                  <a:srgbClr val="F97316"/>
-                </a:solidFill>
-                <a:latin typeface="Georgia" pitchFamily="34" charset="0"/>
-                <a:ea typeface="Georgia" pitchFamily="34" charset="-122"/>
-                <a:cs typeface="Georgia" pitchFamily="34" charset="-120"/>
-              </a:rPr>
-              <a:t>02</a:t>
-            </a:r>
-            <a:endParaRPr lang="en-US" sz="2200" dirty="0"/>
-          </a:p>
-        </p:txBody>
-      </p:sp>
-      <p:sp>
-        <p:nvSpPr>
-          <p:cNvPr id="14" name="Text 12"/>
-          <p:cNvSpPr/>
-          <p:nvPr/>
-        </p:nvSpPr>
-        <p:spPr>
-          <a:xfrm>
-            <a:off x="4591202" y="3127248"/>
-            <a:ext cx="3055010" cy="548640"/>
+            <a:off x="6525616" y="2935224"/>
+            <a:ext cx="4888840" cy="1965960"/>
           </a:xfrm>
           <a:prstGeom prst="rect">
             <a:avLst/>
@@ -20962,34 +21053,137 @@
           </a:bodyPr>
           <a:lstStyle/>
           <a:p>
-            <a:pPr indent="0" marL="0">
-              <a:buNone/>
-            </a:pPr>
-            <a:r>
-              <a:rPr lang="en-US" sz="1300" b="1" dirty="0">
-                <a:solidFill>
-                  <a:srgbClr val="FAF4EE"/>
-                </a:solidFill>
-                <a:latin typeface="Calibri" pitchFamily="34" charset="0"/>
-                <a:ea typeface="Calibri" pitchFamily="34" charset="-122"/>
-                <a:cs typeface="Calibri" pitchFamily="34" charset="-120"/>
-              </a:rPr>
-              <a:t>Report → per-requirement evaluation</a:t>
-            </a:r>
-            <a:endParaRPr lang="en-US" sz="1300" dirty="0"/>
-          </a:p>
-        </p:txBody>
-      </p:sp>
-      <p:sp>
-        <p:nvSpPr>
-          <p:cNvPr id="15" name="Text 13"/>
-          <p:cNvSpPr/>
-          <p:nvPr/>
-        </p:nvSpPr>
-        <p:spPr>
-          <a:xfrm>
-            <a:off x="4591202" y="3694176"/>
-            <a:ext cx="3055010" cy="868680"/>
+            <a:pPr marL="152400" indent="-152400">
+              <a:lnSpc>
+                <a:spcPct val="100000"/>
+              </a:lnSpc>
+              <a:spcAft>
+                <a:spcPts val="600"/>
+              </a:spcAft>
+              <a:buSzPct val="100000"/>
+              <a:buChar char="•"/>
+            </a:pPr>
+            <a:r>
+              <a:rPr lang="en-US" sz="1100" dirty="0">
+                <a:solidFill>
+                  <a:srgbClr val="C9B6A6"/>
+                </a:solidFill>
+                <a:latin typeface="Calibri" pitchFamily="34" charset="0"/>
+                <a:ea typeface="Calibri" pitchFamily="34" charset="-122"/>
+                <a:cs typeface="Calibri" pitchFamily="34" charset="-120"/>
+              </a:rPr>
+              <a:t>The signed agreement is parsed once into structured requirements, deadlines and indicators</a:t>
+            </a:r>
+            <a:endParaRPr lang="en-US" sz="1100" dirty="0"/>
+          </a:p>
+          <a:p>
+            <a:pPr marL="152400" indent="-152400">
+              <a:lnSpc>
+                <a:spcPct val="100000"/>
+              </a:lnSpc>
+              <a:spcAft>
+                <a:spcPts val="600"/>
+              </a:spcAft>
+              <a:buSzPct val="100000"/>
+              <a:buChar char="•"/>
+            </a:pPr>
+            <a:r>
+              <a:rPr lang="en-US" sz="1100" dirty="0">
+                <a:solidFill>
+                  <a:srgbClr val="C9B6A6"/>
+                </a:solidFill>
+                <a:latin typeface="Calibri" pitchFamily="34" charset="0"/>
+                <a:ea typeface="Calibri" pitchFamily="34" charset="-122"/>
+                <a:cs typeface="Calibri" pitchFamily="34" charset="-120"/>
+              </a:rPr>
+              <a:t>Every report arrives already graded — met / partial / missing — per requirement, with citations</a:t>
+            </a:r>
+            <a:endParaRPr lang="en-US" sz="1100" dirty="0"/>
+          </a:p>
+          <a:p>
+            <a:pPr marL="152400" indent="-152400">
+              <a:lnSpc>
+                <a:spcPct val="100000"/>
+              </a:lnSpc>
+              <a:spcAft>
+                <a:spcPts val="600"/>
+              </a:spcAft>
+              <a:buSzPct val="100000"/>
+              <a:buChar char="•"/>
+            </a:pPr>
+            <a:r>
+              <a:rPr lang="en-US" sz="1100" dirty="0">
+                <a:solidFill>
+                  <a:srgbClr val="C9B6A6"/>
+                </a:solidFill>
+                <a:latin typeface="Calibri" pitchFamily="34" charset="0"/>
+                <a:ea typeface="Calibri" pitchFamily="34" charset="-122"/>
+                <a:cs typeface="Calibri" pitchFamily="34" charset="-120"/>
+              </a:rPr>
+              <a:t>AI risk flags surface early in your dashboard, before a quarterly review would catch them</a:t>
+            </a:r>
+            <a:endParaRPr lang="en-US" sz="1100" dirty="0"/>
+          </a:p>
+          <a:p>
+            <a:pPr marL="152400" indent="-152400">
+              <a:lnSpc>
+                <a:spcPct val="100000"/>
+              </a:lnSpc>
+              <a:spcAft>
+                <a:spcPts val="600"/>
+              </a:spcAft>
+              <a:buSzPct val="100000"/>
+              <a:buChar char="•"/>
+            </a:pPr>
+            <a:r>
+              <a:rPr lang="en-US" sz="1100" dirty="0">
+                <a:solidFill>
+                  <a:srgbClr val="C9B6A6"/>
+                </a:solidFill>
+                <a:latin typeface="Calibri" pitchFamily="34" charset="0"/>
+                <a:ea typeface="Calibri" pitchFamily="34" charset="-122"/>
+                <a:cs typeface="Calibri" pitchFamily="34" charset="-120"/>
+              </a:rPr>
+              <a:t>One-click donor pack, in English and the local language</a:t>
+            </a:r>
+            <a:endParaRPr lang="en-US" sz="1100" dirty="0"/>
+          </a:p>
+          <a:p>
+            <a:pPr marL="152400" indent="-152400">
+              <a:lnSpc>
+                <a:spcPct val="100000"/>
+              </a:lnSpc>
+              <a:spcAft>
+                <a:spcPts val="600"/>
+              </a:spcAft>
+              <a:buSzPct val="100000"/>
+              <a:buChar char="•"/>
+            </a:pPr>
+            <a:r>
+              <a:rPr lang="en-US" sz="1100" dirty="0">
+                <a:solidFill>
+                  <a:srgbClr val="C9B6A6"/>
+                </a:solidFill>
+                <a:latin typeface="Calibri" pitchFamily="34" charset="0"/>
+                <a:ea typeface="Calibri" pitchFamily="34" charset="-122"/>
+                <a:cs typeface="Calibri" pitchFamily="34" charset="-120"/>
+              </a:rPr>
+              <a:t>You review the exceptions, not raw submissions</a:t>
+            </a:r>
+            <a:endParaRPr lang="en-US" sz="1100" dirty="0"/>
+          </a:p>
+        </p:txBody>
+      </p:sp>
+      <p:sp>
+        <p:nvSpPr>
+          <p:cNvPr id="14" name="Text 12"/>
+          <p:cNvSpPr/>
+          <p:nvPr/>
+        </p:nvSpPr>
+        <p:spPr>
+          <a:xfrm>
+            <a:off x="502920" y="5577840"/>
+            <a:ext cx="11185855" cy="411480"/>
           </a:xfrm>
           <a:prstGeom prst="rect">
             <a:avLst/>
@@ -21003,22 +21197,39 @@
           </a:bodyPr>
           <a:lstStyle/>
           <a:p>
-            <a:pPr indent="0" marL="0">
+            <a:pPr algn="ctr" indent="0" marL="0">
               <a:lnSpc>
-                <a:spcPct val="103000"/>
+                <a:spcPct val="102000"/>
               </a:lnSpc>
               <a:buNone/>
             </a:pPr>
             <a:r>
+              <a:rPr lang="en-US" sz="1050" b="1" dirty="0">
+                <a:solidFill>
+                  <a:srgbClr val="F0A44A"/>
+                </a:solidFill>
+                <a:latin typeface="Calibri" pitchFamily="34" charset="0"/>
+                <a:ea typeface="Calibri" pitchFamily="34" charset="-122"/>
+                <a:cs typeface="Calibri" pitchFamily="34" charset="-120"/>
+              </a:rPr>
+              <a:t>The moat:  </a:t>
+            </a:r>
+            <a:pPr algn="ctr" indent="0" marL="0">
+              <a:lnSpc>
+                <a:spcPct val="102000"/>
+              </a:lnSpc>
+              <a:buNone/>
+            </a:pPr>
+            <a:r>
               <a:rPr lang="en-US" sz="1050" dirty="0">
                 <a:solidFill>
-                  <a:srgbClr val="C9B6A6"/>
-                </a:solidFill>
-                <a:latin typeface="Calibri" pitchFamily="34" charset="0"/>
-                <a:ea typeface="Calibri" pitchFamily="34" charset="-122"/>
-                <a:cs typeface="Calibri" pitchFamily="34" charset="-120"/>
-              </a:rPr>
-              <a:t>When the NGO submits, AI grades each requirement individually — met, partial, missing — with citations back to the report and the agreement.</a:t>
+                  <a:srgbClr val="8C7A6C"/>
+                </a:solidFill>
+                <a:latin typeface="Calibri" pitchFamily="34" charset="0"/>
+                <a:ea typeface="Calibri" pitchFamily="34" charset="-122"/>
+                <a:cs typeface="Calibri" pitchFamily="34" charset="-120"/>
+              </a:rPr>
+              <a:t>no grant-management system on the market — Submittable, Foundant, Fluxx, Salesforce, Blackbaud, GivingData — evaluates reports against the agreement, per requirement, with citations. Kuja does it in production today.</a:t>
             </a:r>
             <a:endParaRPr lang="en-US" sz="1050" dirty="0"/>
           </a:p>
@@ -21026,268 +21237,7 @@
       </p:sp>
       <p:sp>
         <p:nvSpPr>
-          <p:cNvPr id="16" name="Shape 14"/>
-          <p:cNvSpPr/>
-          <p:nvPr/>
-        </p:nvSpPr>
-        <p:spPr>
-          <a:xfrm>
-            <a:off x="8130845" y="2377440"/>
-            <a:ext cx="3557930" cy="2286000"/>
-          </a:xfrm>
-          <a:prstGeom prst="roundRect">
-            <a:avLst>
-              <a:gd name="adj" fmla="val 3600"/>
-            </a:avLst>
-          </a:prstGeom>
-          <a:solidFill>
-            <a:srgbClr val="271A11"/>
-          </a:solidFill>
-          <a:ln w="12700">
-            <a:solidFill>
-              <a:srgbClr val="4A3122"/>
-            </a:solidFill>
-            <a:prstDash val="solid"/>
-          </a:ln>
-        </p:spPr>
-      </p:sp>
-      <p:sp>
-        <p:nvSpPr>
-          <p:cNvPr id="17" name="Shape 15"/>
-          <p:cNvSpPr/>
-          <p:nvPr/>
-        </p:nvSpPr>
-        <p:spPr>
-          <a:xfrm>
-            <a:off x="8130845" y="2377440"/>
-            <a:ext cx="82296" cy="2286000"/>
-          </a:xfrm>
-          <a:prstGeom prst="roundRect">
-            <a:avLst>
-              <a:gd name="adj" fmla="val 44444"/>
-            </a:avLst>
-          </a:prstGeom>
-          <a:solidFill>
-            <a:srgbClr val="C2410C"/>
-          </a:solidFill>
-          <a:ln/>
-        </p:spPr>
-      </p:sp>
-      <p:sp>
-        <p:nvSpPr>
-          <p:cNvPr id="18" name="Text 16"/>
-          <p:cNvSpPr/>
-          <p:nvPr/>
-        </p:nvSpPr>
-        <p:spPr>
-          <a:xfrm>
-            <a:off x="8405165" y="2596896"/>
-            <a:ext cx="1097280" cy="457200"/>
-          </a:xfrm>
-          <a:prstGeom prst="rect">
-            <a:avLst/>
-          </a:prstGeom>
-          <a:noFill/>
-          <a:ln/>
-        </p:spPr>
-        <p:txBody>
-          <a:bodyPr wrap="square" rtlCol="0" anchor="ctr"/>
-          <a:lstStyle/>
-          <a:p>
-            <a:pPr indent="0" marL="0">
-              <a:buNone/>
-            </a:pPr>
-            <a:r>
-              <a:rPr lang="en-US" sz="2200" b="1" dirty="0">
-                <a:solidFill>
-                  <a:srgbClr val="F97316"/>
-                </a:solidFill>
-                <a:latin typeface="Georgia" pitchFamily="34" charset="0"/>
-                <a:ea typeface="Georgia" pitchFamily="34" charset="-122"/>
-                <a:cs typeface="Georgia" pitchFamily="34" charset="-120"/>
-              </a:rPr>
-              <a:t>03</a:t>
-            </a:r>
-            <a:endParaRPr lang="en-US" sz="2200" dirty="0"/>
-          </a:p>
-        </p:txBody>
-      </p:sp>
-      <p:sp>
-        <p:nvSpPr>
-          <p:cNvPr id="19" name="Text 17"/>
-          <p:cNvSpPr/>
-          <p:nvPr/>
-        </p:nvSpPr>
-        <p:spPr>
-          <a:xfrm>
-            <a:off x="8405165" y="3127248"/>
-            <a:ext cx="3055010" cy="548640"/>
-          </a:xfrm>
-          <a:prstGeom prst="rect">
-            <a:avLst/>
-          </a:prstGeom>
-          <a:noFill/>
-          <a:ln/>
-        </p:spPr>
-        <p:txBody>
-          <a:bodyPr wrap="square" rtlCol="0" anchor="t">
-            <a:normAutofit/>
-          </a:bodyPr>
-          <a:lstStyle/>
-          <a:p>
-            <a:pPr indent="0" marL="0">
-              <a:buNone/>
-            </a:pPr>
-            <a:r>
-              <a:rPr lang="en-US" sz="1300" b="1" dirty="0">
-                <a:solidFill>
-                  <a:srgbClr val="FAF4EE"/>
-                </a:solidFill>
-                <a:latin typeface="Calibri" pitchFamily="34" charset="0"/>
-                <a:ea typeface="Calibri" pitchFamily="34" charset="-122"/>
-                <a:cs typeface="Calibri" pitchFamily="34" charset="-120"/>
-              </a:rPr>
-              <a:t>Compliance score → surfaced early</a:t>
-            </a:r>
-            <a:endParaRPr lang="en-US" sz="1300" dirty="0"/>
-          </a:p>
-        </p:txBody>
-      </p:sp>
-      <p:sp>
-        <p:nvSpPr>
-          <p:cNvPr id="20" name="Text 18"/>
-          <p:cNvSpPr/>
-          <p:nvPr/>
-        </p:nvSpPr>
-        <p:spPr>
-          <a:xfrm>
-            <a:off x="8405165" y="3694176"/>
-            <a:ext cx="3055010" cy="868680"/>
-          </a:xfrm>
-          <a:prstGeom prst="rect">
-            <a:avLst/>
-          </a:prstGeom>
-          <a:noFill/>
-          <a:ln/>
-        </p:spPr>
-        <p:txBody>
-          <a:bodyPr wrap="square" rtlCol="0" anchor="t">
-            <a:normAutofit/>
-          </a:bodyPr>
-          <a:lstStyle/>
-          <a:p>
-            <a:pPr indent="0" marL="0">
-              <a:lnSpc>
-                <a:spcPct val="103000"/>
-              </a:lnSpc>
-              <a:buNone/>
-            </a:pPr>
-            <a:r>
-              <a:rPr lang="en-US" sz="1050" dirty="0">
-                <a:solidFill>
-                  <a:srgbClr val="C9B6A6"/>
-                </a:solidFill>
-                <a:latin typeface="Calibri" pitchFamily="34" charset="0"/>
-                <a:ea typeface="Calibri" pitchFamily="34" charset="-122"/>
-                <a:cs typeface="Calibri" pitchFamily="34" charset="-120"/>
-              </a:rPr>
-              <a:t>Per-requirement grades roll into an overall score; AI risk flags surface in the donor dashboard before a quarterly review would catch them.</a:t>
-            </a:r>
-            <a:endParaRPr lang="en-US" sz="1050" dirty="0"/>
-          </a:p>
-        </p:txBody>
-      </p:sp>
-      <p:sp>
-        <p:nvSpPr>
-          <p:cNvPr id="21" name="Shape 19"/>
-          <p:cNvSpPr/>
-          <p:nvPr/>
-        </p:nvSpPr>
-        <p:spPr>
-          <a:xfrm>
-            <a:off x="502920" y="4864608"/>
-            <a:ext cx="11185855" cy="640080"/>
-          </a:xfrm>
-          <a:prstGeom prst="roundRect">
-            <a:avLst>
-              <a:gd name="adj" fmla="val 14286"/>
-            </a:avLst>
-          </a:prstGeom>
-          <a:solidFill>
-            <a:srgbClr val="211308"/>
-          </a:solidFill>
-          <a:ln w="12700">
-            <a:solidFill>
-              <a:srgbClr val="C2410C"/>
-            </a:solidFill>
-            <a:prstDash val="solid"/>
-          </a:ln>
-        </p:spPr>
-      </p:sp>
-      <p:sp>
-        <p:nvSpPr>
-          <p:cNvPr id="22" name="Text 20"/>
-          <p:cNvSpPr/>
-          <p:nvPr/>
-        </p:nvSpPr>
-        <p:spPr>
-          <a:xfrm>
-            <a:off x="777240" y="4864608"/>
-            <a:ext cx="10637215" cy="640080"/>
-          </a:xfrm>
-          <a:prstGeom prst="rect">
-            <a:avLst/>
-          </a:prstGeom>
-          <a:noFill/>
-          <a:ln/>
-        </p:spPr>
-        <p:txBody>
-          <a:bodyPr wrap="square" rtlCol="0" anchor="ctr">
-            <a:normAutofit/>
-          </a:bodyPr>
-          <a:lstStyle/>
-          <a:p>
-            <a:pPr indent="0" marL="0">
-              <a:lnSpc>
-                <a:spcPct val="100000"/>
-              </a:lnSpc>
-              <a:buNone/>
-            </a:pPr>
-            <a:r>
-              <a:rPr lang="en-US" sz="1100" b="1" dirty="0">
-                <a:solidFill>
-                  <a:srgbClr val="F0A44A"/>
-                </a:solidFill>
-                <a:latin typeface="Calibri" pitchFamily="34" charset="0"/>
-                <a:ea typeface="Calibri" pitchFamily="34" charset="-122"/>
-                <a:cs typeface="Calibri" pitchFamily="34" charset="-120"/>
-              </a:rPr>
-              <a:t>Why this is the headline:  </a:t>
-            </a:r>
-            <a:pPr indent="0" marL="0">
-              <a:lnSpc>
-                <a:spcPct val="100000"/>
-              </a:lnSpc>
-              <a:buNone/>
-            </a:pPr>
-            <a:r>
-              <a:rPr lang="en-US" sz="1100" dirty="0">
-                <a:solidFill>
-                  <a:srgbClr val="C9B6A6"/>
-                </a:solidFill>
-                <a:latin typeface="Calibri" pitchFamily="34" charset="0"/>
-                <a:ea typeface="Calibri" pitchFamily="34" charset="-122"/>
-                <a:cs typeface="Calibri" pitchFamily="34" charset="-120"/>
-              </a:rPr>
-              <a:t>no grant-management system on the market — Submittable, Foundant (+SmartSimple), Fluxx, Salesforce, Blackbaud, GivingData — evaluates reports against the agreement, per requirement, with citations. Kuja does it in production today.</a:t>
-            </a:r>
-            <a:endParaRPr lang="en-US" sz="1100" dirty="0"/>
-          </a:p>
-        </p:txBody>
-      </p:sp>
-      <p:sp>
-        <p:nvSpPr>
-          <p:cNvPr id="23" name="Text 21"/>
+          <p:cNvPr id="15" name="Text 13"/>
           <p:cNvSpPr/>
           <p:nvPr/>
         </p:nvSpPr>
@@ -21326,7 +21276,7 @@
       </p:sp>
       <p:sp>
         <p:nvSpPr>
-          <p:cNvPr id="24" name="Text 22"/>
+          <p:cNvPr id="16" name="Text 14"/>
           <p:cNvSpPr/>
           <p:nvPr/>
         </p:nvSpPr>
@@ -21365,7 +21315,7 @@
       </p:sp>
       <p:sp>
         <p:nvSpPr>
-          <p:cNvPr id="25" name="Text 23"/>
+          <p:cNvPr id="17" name="Text 15"/>
           <p:cNvSpPr/>
           <p:nvPr/>
         </p:nvSpPr>
@@ -21404,7 +21354,7 @@
       </p:sp>
       <p:sp>
         <p:nvSpPr>
-          <p:cNvPr id="26" name="Shape 24"/>
+          <p:cNvPr id="18" name="Shape 16"/>
           <p:cNvSpPr/>
           <p:nvPr/>
         </p:nvSpPr>

</xml_diff>

<commit_message>
Grant Deck V6: add Spanish to prominent six-language list
Spanish now appears alongside Somali/Swahili/Arabic/French in the title
subtitle, the slide-10 accessibility hero card, and the slide-15 'why we
win' language advantage — English kept as the sixth. Prior version listed
Spanish only parenthetically.

Co-Authored-By: Claude Opus 4.8 <noreply@anthropic.com>
</commit_message>
<xml_diff>
--- a/docs/Kuja_Grant_Pitch_Deck_V6_Aug2026.pptx
+++ b/docs/Kuja_Grant_Pitch_Deck_V6_Aug2026.pptx
@@ -2562,7 +2562,7 @@
                 <a:ea typeface="Calibri" pitchFamily="34" charset="-122"/>
                 <a:cs typeface="Calibri" pitchFamily="34" charset="-120"/>
               </a:rPr>
-              <a:t>Somali · Swahili · Arabic · French</a:t>
+              <a:t>Somali · Swahili · Arabic · French · Spanish</a:t>
             </a:r>
             <a:pPr indent="0" marL="0">
               <a:buNone/>
@@ -2576,7 +2576,7 @@
                 <a:ea typeface="Calibri" pitchFamily="34" charset="-122"/>
                 <a:cs typeface="Calibri" pitchFamily="34" charset="-120"/>
               </a:rPr>
-              <a:t> · English · Spanish  ·  Production-deployed today</a:t>
+              <a:t> · English  ·  Production-deployed today</a:t>
             </a:r>
             <a:endParaRPr lang="en-US" sz="1200" dirty="0"/>
           </a:p>
@@ -2867,7 +2867,7 @@
                 <a:ea typeface="Calibri" pitchFamily="34" charset="-122"/>
                 <a:cs typeface="Calibri" pitchFamily="34" charset="-120"/>
               </a:rPr>
-              <a:t>Full parity in Somali, Swahili, Arabic and French — plus WhatsApp, voice, photos and mobile-first. The way Global South work actually happens, not a desktop form in English.</a:t>
+              <a:t>Full parity in Somali, Swahili, Arabic, French and Spanish — plus WhatsApp, voice, photos and mobile-first. The way Global South work actually happens, not a desktop form in English.</a:t>
             </a:r>
             <a:endParaRPr lang="en-US" sz="1450" dirty="0"/>
           </a:p>
@@ -2957,7 +2957,7 @@
                 <a:ea typeface="Calibri" pitchFamily="34" charset="-122"/>
                 <a:cs typeface="Calibri" pitchFamily="34" charset="-120"/>
               </a:rPr>
-              <a:t>Somali · Swahili · Arabic · French</a:t>
+              <a:t>Somali · Swahili · Arabic · French · Spanish</a:t>
             </a:r>
             <a:endParaRPr lang="en-US" sz="1250" dirty="0"/>
           </a:p>
@@ -3001,7 +3001,7 @@
                 <a:ea typeface="Calibri" pitchFamily="34" charset="-122"/>
                 <a:cs typeface="Calibri" pitchFamily="34" charset="-120"/>
               </a:rPr>
-              <a:t>Six-language parity at the WORKFLOW level (with English &amp; Spanish) — not translated strings, but translated AI behaviour. Our core advantage in markets mainstream tools ignore.</a:t>
+              <a:t>Six-language parity at the WORKFLOW level (with English) — not translated strings, but translated AI behaviour. Our core advantage in markets mainstream tools ignore.</a:t>
             </a:r>
             <a:endParaRPr lang="en-US" sz="1050" dirty="0"/>
           </a:p>
@@ -12035,7 +12035,7 @@
                 <a:ea typeface="Calibri" pitchFamily="34" charset="-122"/>
                 <a:cs typeface="Calibri" pitchFamily="34" charset="-120"/>
               </a:rPr>
-              <a:t>Full parity in Somali, Swahili, Arabic and French (plus English &amp; Spanish). WhatsApp, voice, photo, mobile-first — designed for the Tecno phone on 3G, not localized after the fact.</a:t>
+              <a:t>Full parity in Somali, Swahili, Arabic, French and Spanish (plus English). WhatsApp, voice, photo, mobile-first — designed for the Tecno phone on 3G, not localized after the fact.</a:t>
             </a:r>
             <a:endParaRPr lang="en-US" sz="980" dirty="0"/>
           </a:p>

</xml_diff>